<commit_message>
Fase 2b: modelo despacho calibrado pelo SIA, simulacao e material de apoio
- modelo despacho (unidade disponivel mais proxima, ocupacao q) ao lado do Huff,
  que continua padrao; restricao opcional de cobertura do pior decil
- coleta da producao do SAMU-SP no SIA/SUS e estimativa de q e theta
  (demanda_samu, sp_utilizacao.json)
- varredura do NSGA-II por cenario de q (roda_tudo, sensib_q) e validacao por
  simulacao de eventos discretos (simula, sp_simulacao.json)
- deck da fase 2b com fontes e links, revisao de literatura, CONTEXTO e docs
  atualizados; CLAUDE.md com as regras de trabalho

Co-Authored-By: Claude Opus 5.5 <noreply@anthropic.com>
</commit_message>
<xml_diff>
--- a/fase2_sao_paulo/docs/apresentacao_didatica_samu.pptx
+++ b/fase2_sao_paulo/docs/apresentacao_didatica_samu.pptx
@@ -3767,7 +3767,7 @@
       </p:sp>
       <p:pic>
         <p:nvPicPr>
-          <p:cNvPr id="6" name="Image 0" descr="D:\Estudos\MECAI\Disciplinas\Estatística e Probabilidade\Projeto SAMU\samu-usb-usa\figs\fase2\formulas\n_ef.png">    </p:cNvPr>
+          <p:cNvPr id="6" name="Image 0" descr="C:\Users\lucas\Documents\MECAI\Estatistica\samu-usb-usa\figs\fase2\formulas\n_ef.png">    </p:cNvPr>
           <p:cNvPicPr>
             <a:picLocks noChangeAspect="1"/>
           </p:cNvPicPr>
@@ -3781,8 +3781,8 @@
         </p:blipFill>
         <p:spPr>
           <a:xfrm>
-            <a:off x="932688" y="1554480"/>
-            <a:ext cx="1374851" cy="621792"/>
+            <a:off x="841248" y="1664208"/>
+            <a:ext cx="3410660" cy="420624"/>
           </a:xfrm>
           <a:prstGeom prst="rect">
             <a:avLst/>
@@ -3797,8 +3797,8 @@
         </p:nvSpPr>
         <p:spPr>
           <a:xfrm>
-            <a:off x="5961888" y="1600200"/>
-            <a:ext cx="5486400" cy="685800"/>
+            <a:off x="4636008" y="1554480"/>
+            <a:ext cx="6812280" cy="658368"/>
           </a:xfrm>
           <a:prstGeom prst="rect">
             <a:avLst/>
@@ -3825,7 +3825,7 @@
                 <a:ea typeface="Calibri" pitchFamily="34" charset="-122"/>
                 <a:cs typeface="Calibri" pitchFamily="34" charset="-120"/>
               </a:rPr>
-              <a:t>quantas opções o setor i tem "na prática": 1 se toda probabilidade está numa base só; k se está dividida igualmente entre k bases.</a:t>
+              <a:t>quantas opções o setor i tem "na prática": 1 se toda probabilidade está numa base só; k se está dividida igualmente entre k bases. H é a entropia — a incerteza da escolha. No exemplo do slide 8 (86% / 14%): N_ef = 1,49.</a:t>
             </a:r>
             <a:endParaRPr lang="en-US" sz="1150" dirty="0"/>
           </a:p>
@@ -5961,7 +5961,7 @@
       </p:sp>
       <p:pic>
         <p:nvPicPr>
-          <p:cNvPr id="6" name="Image 0" descr="D:\Estudos\MECAI\Disciplinas\Estatística e Probabilidade\Projeto SAMU\samu-usb-usa\figs\fase2\formulas\sfca_pressao.png">    </p:cNvPr>
+          <p:cNvPr id="6" name="Image 0" descr="C:\Users\lucas\Documents\MECAI\Estatistica\samu-usb-usa\figs\fase2\formulas\sfca_pressao.png">    </p:cNvPr>
           <p:cNvPicPr>
             <a:picLocks noChangeAspect="1"/>
           </p:cNvPicPr>
@@ -5985,7 +5985,7 @@
       </p:pic>
       <p:pic>
         <p:nvPicPr>
-          <p:cNvPr id="7" name="Image 1" descr="D:\Estudos\MECAI\Disciplinas\Estatística e Probabilidade\Projeto SAMU\samu-usb-usa\figs\fase2\formulas\sfca_razao.png">    </p:cNvPr>
+          <p:cNvPr id="7" name="Image 1" descr="C:\Users\lucas\Documents\MECAI\Estatistica\samu-usb-usa\figs\fase2\formulas\sfca_razao.png">    </p:cNvPr>
           <p:cNvPicPr>
             <a:picLocks noChangeAspect="1"/>
           </p:cNvPicPr>
@@ -7068,7 +7068,7 @@
       </p:sp>
       <p:pic>
         <p:nvPicPr>
-          <p:cNvPr id="6" name="Image 0" descr="D:\Estudos\MECAI\Disciplinas\Estatística e Probabilidade\Projeto SAMU\samu-usb-usa\figs\fase2\formulas\sfca_acessibilidade.png">    </p:cNvPr>
+          <p:cNvPr id="6" name="Image 0" descr="C:\Users\lucas\Documents\MECAI\Estatistica\samu-usb-usa\figs\fase2\formulas\sfca_acessibilidade.png">    </p:cNvPr>
           <p:cNvPicPr>
             <a:picLocks noChangeAspect="1"/>
           </p:cNvPicPr>
@@ -8714,7 +8714,7 @@
       </p:sp>
       <p:pic>
         <p:nvPicPr>
-          <p:cNvPr id="7" name="Image 0" descr="D:\Estudos\MECAI\Disciplinas\Estatística e Probabilidade\Projeto SAMU\samu-usb-usa\figs\fase2\formulas\lorenz_xy.png">    </p:cNvPr>
+          <p:cNvPr id="7" name="Image 0" descr="C:\Users\lucas\Documents\MECAI\Estatistica\samu-usb-usa\figs\fase2\formulas\lorenz_xy.png">    </p:cNvPr>
           <p:cNvPicPr>
             <a:picLocks noChangeAspect="1"/>
           </p:cNvPicPr>
@@ -8843,7 +8843,7 @@
       </p:sp>
       <p:pic>
         <p:nvPicPr>
-          <p:cNvPr id="11" name="Image 1" descr="D:\Estudos\MECAI\Disciplinas\Estatística e Probabilidade\Projeto SAMU\samu-usb-usa\figs\fase2\formulas\lorenz_gini.png">    </p:cNvPr>
+          <p:cNvPr id="11" name="Image 1" descr="C:\Users\lucas\Documents\MECAI\Estatistica\samu-usb-usa\figs\fase2\formulas\lorenz_gini.png">    </p:cNvPr>
           <p:cNvPicPr>
             <a:picLocks noChangeAspect="1"/>
           </p:cNvPicPr>
@@ -14332,7 +14332,7 @@
       </p:sp>
       <p:pic>
         <p:nvPicPr>
-          <p:cNvPr id="6" name="Image 0" descr="D:\Estudos\MECAI\Disciplinas\Estatística e Probabilidade\Projeto SAMU\samu-usb-usa\figs\fase2\formulas\pmedian_obj.png">    </p:cNvPr>
+          <p:cNvPr id="6" name="Image 0" descr="C:\Users\lucas\Documents\MECAI\Estatistica\samu-usb-usa\figs\fase2\formulas\pmedian_obj.png">    </p:cNvPr>
           <p:cNvPicPr>
             <a:picLocks noChangeAspect="1"/>
           </p:cNvPicPr>
@@ -16192,7 +16192,7 @@
       </p:sp>
       <p:pic>
         <p:nvPicPr>
-          <p:cNvPr id="6" name="Image 0" descr="D:\Estudos\MECAI\Disciplinas\Estatística e Probabilidade\Projeto SAMU\samu-usb-usa\figs\fase2\formulas\lambda_obj.png">    </p:cNvPr>
+          <p:cNvPr id="6" name="Image 0" descr="C:\Users\lucas\Documents\MECAI\Estatistica\samu-usb-usa\figs\fase2\formulas\lambda_obj.png">    </p:cNvPr>
           <p:cNvPicPr>
             <a:picLocks noChangeAspect="1"/>
           </p:cNvPicPr>
@@ -17368,7 +17368,7 @@
       </p:sp>
       <p:pic>
         <p:nvPicPr>
-          <p:cNvPr id="5" name="Image 0" descr="D:\Estudos\MECAI\Disciplinas\Estatística e Probabilidade\Projeto SAMU\samu-usb-usa\figs\fase2\sp_02_ganho_km.png">    </p:cNvPr>
+          <p:cNvPr id="5" name="Image 0" descr="C:\Users\lucas\Documents\MECAI\Estatistica\samu-usb-usa\figs\fase2\sp_02_ganho_km.png">    </p:cNvPr>
           <p:cNvPicPr>
             <a:picLocks noChangeAspect="1"/>
           </p:cNvPicPr>
@@ -17730,7 +17730,7 @@
       </p:sp>
       <p:pic>
         <p:nvPicPr>
-          <p:cNvPr id="5" name="Image 0" descr="D:\Estudos\MECAI\Disciplinas\Estatística e Probabilidade\Projeto SAMU\samu-usb-usa\figs\fase2\sp_05_comparacao.png">    </p:cNvPr>
+          <p:cNvPr id="5" name="Image 0" descr="C:\Users\lucas\Documents\MECAI\Estatistica\samu-usb-usa\figs\fase2\sp_05_comparacao.png">    </p:cNvPr>
           <p:cNvPicPr>
             <a:picLocks noChangeAspect="1"/>
           </p:cNvPicPr>
@@ -18185,7 +18185,7 @@
       </p:sp>
       <p:pic>
         <p:nvPicPr>
-          <p:cNvPr id="6" name="Image 0" descr="D:\Estudos\MECAI\Disciplinas\Estatística e Probabilidade\Projeto SAMU\samu-usb-usa\figs\fase2\formulas\rho_g.png">    </p:cNvPr>
+          <p:cNvPr id="6" name="Image 0" descr="C:\Users\lucas\Documents\MECAI\Estatistica\samu-usb-usa\figs\fase2\formulas\rho_g.png">    </p:cNvPr>
           <p:cNvPicPr>
             <a:picLocks noChangeAspect="1"/>
           </p:cNvPicPr>
@@ -24129,7 +24129,7 @@
       </p:sp>
       <p:pic>
         <p:nvPicPr>
-          <p:cNvPr id="6" name="Image 0" descr="D:\Estudos\MECAI\Disciplinas\Estatística e Probabilidade\Projeto SAMU\samu-usb-usa\figs\fase2\formulas\huff_principal.png">    </p:cNvPr>
+          <p:cNvPr id="6" name="Image 0" descr="C:\Users\lucas\Documents\MECAI\Estatistica\samu-usb-usa\figs\fase2\formulas\huff_principal.png">    </p:cNvPr>
           <p:cNvPicPr>
             <a:picLocks noChangeAspect="1"/>
           </p:cNvPicPr>
@@ -24153,7 +24153,7 @@
       </p:pic>
       <p:pic>
         <p:nvPicPr>
-          <p:cNvPr id="7" name="Image 1" descr="D:\Estudos\MECAI\Disciplinas\Estatística e Probabilidade\Projeto SAMU\samu-usb-usa\figs\fase2\formulas\huff_decaimento.png">    </p:cNvPr>
+          <p:cNvPr id="7" name="Image 1" descr="C:\Users\lucas\Documents\MECAI\Estatistica\samu-usb-usa\figs\fase2\formulas\huff_decaimento.png">    </p:cNvPr>
           <p:cNvPicPr>
             <a:picLocks noChangeAspect="1"/>
           </p:cNvPicPr>
@@ -25057,7 +25057,7 @@
       </p:sp>
       <p:pic>
         <p:nvPicPr>
-          <p:cNvPr id="8" name="Image 0" descr="D:\Estudos\MECAI\Disciplinas\Estatística e Probabilidade\Projeto SAMU\samu-usb-usa\figs\fase2\formulas\beta_subst.png">    </p:cNvPr>
+          <p:cNvPr id="8" name="Image 0" descr="C:\Users\lucas\Documents\MECAI\Estatistica\samu-usb-usa\figs\fase2\formulas\beta_subst.png">    </p:cNvPr>
           <p:cNvPicPr>
             <a:picLocks noChangeAspect="1"/>
           </p:cNvPicPr>

</xml_diff>